<commit_message>
Add verified base paper (Nolasco et al. 2023) to ESC-50 report; restructure deck to match reference order
Co-Authored-By: Claude Sonnet 5.5 <noreply@anthropic.com>
Claude-Session: https://claude.ai/code/session_012DKUQj8phYpnuRrxK5eNsm
</commit_message>
<xml_diff>
--- a/esc50_matching/docs/presentation.pptx
+++ b/esc50_matching/docs/presentation.pptx
@@ -3504,7 +3504,7 @@
                 </a:solidFill>
                 <a:latin typeface="Calibri"/>
               </a:rPr>
-              <a:t>1  Introduction</a:t>
+              <a:t>Index</a:t>
             </a:r>
           </a:p>
         </p:txBody>
@@ -3556,8 +3556,8 @@
         </p:nvSpPr>
         <p:spPr>
           <a:xfrm>
-            <a:off x="457200" y="1188720"/>
-            <a:ext cx="6400800" cy="5120640"/>
+            <a:off x="1097280" y="1188720"/>
+            <a:ext cx="914400" cy="548640"/>
           </a:xfrm>
           <a:prstGeom prst="rect">
             <a:avLst/>
@@ -3576,90 +3576,617 @@
               </a:spcAft>
             </a:pPr>
             <a:r>
-              <a:rPr sz="1800" b="0">
-                <a:latin typeface="Calibri"/>
-              </a:rPr>
-              <a:t>•  Goal: find where a known sound occurs in a longer recording</a:t>
-            </a:r>
-          </a:p>
-          <a:p>
-            <a:pPr>
-              <a:spcAft>
-                <a:spcPts val="600"/>
-              </a:spcAft>
-            </a:pPr>
-            <a:r>
-              <a:rPr sz="1800" b="0">
-                <a:latin typeface="Calibri"/>
-              </a:rPr>
-              <a:t>•  Method: slide the template along the recording; score every position with normalised cross-correlation (NCC) [4], [7]</a:t>
-            </a:r>
-          </a:p>
-          <a:p>
-            <a:pPr>
-              <a:spcAft>
-                <a:spcPts val="600"/>
-              </a:spcAft>
-            </a:pPr>
-            <a:r>
-              <a:rPr sz="1800" b="0">
-                <a:latin typeface="Calibri"/>
-              </a:rPr>
-              <a:t>•  Dividing by window and template energy makes the score volume-independent, in [-1, 1]</a:t>
-            </a:r>
-          </a:p>
-          <a:p>
-            <a:pPr>
-              <a:spcAft>
-                <a:spcPts val="600"/>
-              </a:spcAft>
-            </a:pPr>
-            <a:r>
-              <a:rPr sz="1800" b="0">
-                <a:latin typeface="Calibri"/>
-              </a:rPr>
-              <a:t>•  Test data: ESC-50 [1], [2] clips joined with 1 s silences, so true positions are known</a:t>
-            </a:r>
-          </a:p>
-          <a:p>
-            <a:pPr>
-              <a:spcAft>
-                <a:spcPts val="600"/>
-              </a:spcAft>
-            </a:pPr>
-            <a:r>
-              <a:rPr sz="1800" b="0">
-                <a:latin typeface="Calibri"/>
-              </a:rPr>
-              <a:t>•  ESC-50: 2,000 clips, 50 classes, 5 s, 44.1 kHz; CC BY-NC 3.0 [3]; we use 5 classes at 16 kHz</a:t>
-            </a:r>
-          </a:p>
-        </p:txBody>
-      </p:sp>
-      <p:pic>
-        <p:nvPicPr>
-          <p:cNvPr id="6" name="Picture 5" descr="fig_example.png"/>
-          <p:cNvPicPr>
-            <a:picLocks noChangeAspect="1"/>
-          </p:cNvPicPr>
+              <a:rPr sz="2400" b="1">
+                <a:solidFill>
+                  <a:srgbClr val="0072B2"/>
+                </a:solidFill>
+                <a:latin typeface="Calibri"/>
+              </a:rPr>
+              <a:t>01</a:t>
+            </a:r>
+          </a:p>
+        </p:txBody>
+      </p:sp>
+      <p:sp>
+        <p:nvSpPr>
+          <p:cNvPr id="6" name="TextBox 5"/>
+          <p:cNvSpPr txBox="1"/>
           <p:nvPr/>
-        </p:nvPicPr>
-        <p:blipFill>
-          <a:blip r:embed="rId2"/>
-          <a:stretch>
-            <a:fillRect/>
-          </a:stretch>
-        </p:blipFill>
-        <p:spPr>
-          <a:xfrm>
-            <a:off x="7040880" y="1280160"/>
-            <a:ext cx="4846320" cy="3336424"/>
+        </p:nvSpPr>
+        <p:spPr>
+          <a:xfrm>
+            <a:off x="2194560" y="1188720"/>
+            <a:ext cx="8229600" cy="548640"/>
           </a:xfrm>
           <a:prstGeom prst="rect">
             <a:avLst/>
           </a:prstGeom>
-        </p:spPr>
-      </p:pic>
+          <a:noFill/>
+        </p:spPr>
+        <p:txBody>
+          <a:bodyPr wrap="square">
+            <a:spAutoFit/>
+          </a:bodyPr>
+          <a:lstStyle/>
+          <a:p>
+            <a:pPr>
+              <a:spcAft>
+                <a:spcPts val="600"/>
+              </a:spcAft>
+            </a:pPr>
+            <a:r>
+              <a:rPr sz="2400" b="0">
+                <a:latin typeface="Calibri"/>
+              </a:rPr>
+              <a:t>Title</a:t>
+            </a:r>
+          </a:p>
+        </p:txBody>
+      </p:sp>
+      <p:sp>
+        <p:nvSpPr>
+          <p:cNvPr id="7" name="TextBox 6"/>
+          <p:cNvSpPr txBox="1"/>
+          <p:nvPr/>
+        </p:nvSpPr>
+        <p:spPr>
+          <a:xfrm>
+            <a:off x="1097280" y="1810512"/>
+            <a:ext cx="914400" cy="548640"/>
+          </a:xfrm>
+          <a:prstGeom prst="rect">
+            <a:avLst/>
+          </a:prstGeom>
+          <a:noFill/>
+        </p:spPr>
+        <p:txBody>
+          <a:bodyPr wrap="square">
+            <a:spAutoFit/>
+          </a:bodyPr>
+          <a:lstStyle/>
+          <a:p>
+            <a:pPr>
+              <a:spcAft>
+                <a:spcPts val="600"/>
+              </a:spcAft>
+            </a:pPr>
+            <a:r>
+              <a:rPr sz="2400" b="1">
+                <a:solidFill>
+                  <a:srgbClr val="0072B2"/>
+                </a:solidFill>
+                <a:latin typeface="Calibri"/>
+              </a:rPr>
+              <a:t>02</a:t>
+            </a:r>
+          </a:p>
+        </p:txBody>
+      </p:sp>
+      <p:sp>
+        <p:nvSpPr>
+          <p:cNvPr id="8" name="TextBox 7"/>
+          <p:cNvSpPr txBox="1"/>
+          <p:nvPr/>
+        </p:nvSpPr>
+        <p:spPr>
+          <a:xfrm>
+            <a:off x="2194560" y="1810512"/>
+            <a:ext cx="8229600" cy="548640"/>
+          </a:xfrm>
+          <a:prstGeom prst="rect">
+            <a:avLst/>
+          </a:prstGeom>
+          <a:noFill/>
+        </p:spPr>
+        <p:txBody>
+          <a:bodyPr wrap="square">
+            <a:spAutoFit/>
+          </a:bodyPr>
+          <a:lstStyle/>
+          <a:p>
+            <a:pPr>
+              <a:spcAft>
+                <a:spcPts val="600"/>
+              </a:spcAft>
+            </a:pPr>
+            <a:r>
+              <a:rPr sz="2400" b="0">
+                <a:latin typeface="Calibri"/>
+              </a:rPr>
+              <a:t>Index</a:t>
+            </a:r>
+          </a:p>
+        </p:txBody>
+      </p:sp>
+      <p:sp>
+        <p:nvSpPr>
+          <p:cNvPr id="9" name="TextBox 8"/>
+          <p:cNvSpPr txBox="1"/>
+          <p:nvPr/>
+        </p:nvSpPr>
+        <p:spPr>
+          <a:xfrm>
+            <a:off x="1097280" y="2432304"/>
+            <a:ext cx="914400" cy="548640"/>
+          </a:xfrm>
+          <a:prstGeom prst="rect">
+            <a:avLst/>
+          </a:prstGeom>
+          <a:noFill/>
+        </p:spPr>
+        <p:txBody>
+          <a:bodyPr wrap="square">
+            <a:spAutoFit/>
+          </a:bodyPr>
+          <a:lstStyle/>
+          <a:p>
+            <a:pPr>
+              <a:spcAft>
+                <a:spcPts val="600"/>
+              </a:spcAft>
+            </a:pPr>
+            <a:r>
+              <a:rPr sz="2400" b="1">
+                <a:solidFill>
+                  <a:srgbClr val="0072B2"/>
+                </a:solidFill>
+                <a:latin typeface="Calibri"/>
+              </a:rPr>
+              <a:t>03</a:t>
+            </a:r>
+          </a:p>
+        </p:txBody>
+      </p:sp>
+      <p:sp>
+        <p:nvSpPr>
+          <p:cNvPr id="10" name="TextBox 9"/>
+          <p:cNvSpPr txBox="1"/>
+          <p:nvPr/>
+        </p:nvSpPr>
+        <p:spPr>
+          <a:xfrm>
+            <a:off x="2194560" y="2432304"/>
+            <a:ext cx="8229600" cy="548640"/>
+          </a:xfrm>
+          <a:prstGeom prst="rect">
+            <a:avLst/>
+          </a:prstGeom>
+          <a:noFill/>
+        </p:spPr>
+        <p:txBody>
+          <a:bodyPr wrap="square">
+            <a:spAutoFit/>
+          </a:bodyPr>
+          <a:lstStyle/>
+          <a:p>
+            <a:pPr>
+              <a:spcAft>
+                <a:spcPts val="600"/>
+              </a:spcAft>
+            </a:pPr>
+            <a:r>
+              <a:rPr sz="2400" b="0">
+                <a:latin typeface="Calibri"/>
+              </a:rPr>
+              <a:t>Comparative Study of Literature</a:t>
+            </a:r>
+          </a:p>
+        </p:txBody>
+      </p:sp>
+      <p:sp>
+        <p:nvSpPr>
+          <p:cNvPr id="11" name="TextBox 10"/>
+          <p:cNvSpPr txBox="1"/>
+          <p:nvPr/>
+        </p:nvSpPr>
+        <p:spPr>
+          <a:xfrm>
+            <a:off x="1097280" y="3054096"/>
+            <a:ext cx="914400" cy="548640"/>
+          </a:xfrm>
+          <a:prstGeom prst="rect">
+            <a:avLst/>
+          </a:prstGeom>
+          <a:noFill/>
+        </p:spPr>
+        <p:txBody>
+          <a:bodyPr wrap="square">
+            <a:spAutoFit/>
+          </a:bodyPr>
+          <a:lstStyle/>
+          <a:p>
+            <a:pPr>
+              <a:spcAft>
+                <a:spcPts val="600"/>
+              </a:spcAft>
+            </a:pPr>
+            <a:r>
+              <a:rPr sz="2400" b="1">
+                <a:solidFill>
+                  <a:srgbClr val="0072B2"/>
+                </a:solidFill>
+                <a:latin typeface="Calibri"/>
+              </a:rPr>
+              <a:t>04</a:t>
+            </a:r>
+          </a:p>
+        </p:txBody>
+      </p:sp>
+      <p:sp>
+        <p:nvSpPr>
+          <p:cNvPr id="12" name="TextBox 11"/>
+          <p:cNvSpPr txBox="1"/>
+          <p:nvPr/>
+        </p:nvSpPr>
+        <p:spPr>
+          <a:xfrm>
+            <a:off x="2194560" y="3054096"/>
+            <a:ext cx="8229600" cy="548640"/>
+          </a:xfrm>
+          <a:prstGeom prst="rect">
+            <a:avLst/>
+          </a:prstGeom>
+          <a:noFill/>
+        </p:spPr>
+        <p:txBody>
+          <a:bodyPr wrap="square">
+            <a:spAutoFit/>
+          </a:bodyPr>
+          <a:lstStyle/>
+          <a:p>
+            <a:pPr>
+              <a:spcAft>
+                <a:spcPts val="600"/>
+              </a:spcAft>
+            </a:pPr>
+            <a:r>
+              <a:rPr sz="2400" b="0">
+                <a:latin typeface="Calibri"/>
+              </a:rPr>
+              <a:t>Objective</a:t>
+            </a:r>
+          </a:p>
+        </p:txBody>
+      </p:sp>
+      <p:sp>
+        <p:nvSpPr>
+          <p:cNvPr id="13" name="TextBox 12"/>
+          <p:cNvSpPr txBox="1"/>
+          <p:nvPr/>
+        </p:nvSpPr>
+        <p:spPr>
+          <a:xfrm>
+            <a:off x="1097280" y="3675888"/>
+            <a:ext cx="914400" cy="548640"/>
+          </a:xfrm>
+          <a:prstGeom prst="rect">
+            <a:avLst/>
+          </a:prstGeom>
+          <a:noFill/>
+        </p:spPr>
+        <p:txBody>
+          <a:bodyPr wrap="square">
+            <a:spAutoFit/>
+          </a:bodyPr>
+          <a:lstStyle/>
+          <a:p>
+            <a:pPr>
+              <a:spcAft>
+                <a:spcPts val="600"/>
+              </a:spcAft>
+            </a:pPr>
+            <a:r>
+              <a:rPr sz="2400" b="1">
+                <a:solidFill>
+                  <a:srgbClr val="0072B2"/>
+                </a:solidFill>
+                <a:latin typeface="Calibri"/>
+              </a:rPr>
+              <a:t>05</a:t>
+            </a:r>
+          </a:p>
+        </p:txBody>
+      </p:sp>
+      <p:sp>
+        <p:nvSpPr>
+          <p:cNvPr id="14" name="TextBox 13"/>
+          <p:cNvSpPr txBox="1"/>
+          <p:nvPr/>
+        </p:nvSpPr>
+        <p:spPr>
+          <a:xfrm>
+            <a:off x="2194560" y="3675888"/>
+            <a:ext cx="8229600" cy="548640"/>
+          </a:xfrm>
+          <a:prstGeom prst="rect">
+            <a:avLst/>
+          </a:prstGeom>
+          <a:noFill/>
+        </p:spPr>
+        <p:txBody>
+          <a:bodyPr wrap="square">
+            <a:spAutoFit/>
+          </a:bodyPr>
+          <a:lstStyle/>
+          <a:p>
+            <a:pPr>
+              <a:spcAft>
+                <a:spcPts val="600"/>
+              </a:spcAft>
+            </a:pPr>
+            <a:r>
+              <a:rPr sz="2400" b="0">
+                <a:latin typeface="Calibri"/>
+              </a:rPr>
+              <a:t>Methodology (Flow Chart)</a:t>
+            </a:r>
+          </a:p>
+        </p:txBody>
+      </p:sp>
+      <p:sp>
+        <p:nvSpPr>
+          <p:cNvPr id="15" name="TextBox 14"/>
+          <p:cNvSpPr txBox="1"/>
+          <p:nvPr/>
+        </p:nvSpPr>
+        <p:spPr>
+          <a:xfrm>
+            <a:off x="1097280" y="4297680"/>
+            <a:ext cx="914400" cy="548640"/>
+          </a:xfrm>
+          <a:prstGeom prst="rect">
+            <a:avLst/>
+          </a:prstGeom>
+          <a:noFill/>
+        </p:spPr>
+        <p:txBody>
+          <a:bodyPr wrap="square">
+            <a:spAutoFit/>
+          </a:bodyPr>
+          <a:lstStyle/>
+          <a:p>
+            <a:pPr>
+              <a:spcAft>
+                <a:spcPts val="600"/>
+              </a:spcAft>
+            </a:pPr>
+            <a:r>
+              <a:rPr sz="2400" b="1">
+                <a:solidFill>
+                  <a:srgbClr val="0072B2"/>
+                </a:solidFill>
+                <a:latin typeface="Calibri"/>
+              </a:rPr>
+              <a:t>06</a:t>
+            </a:r>
+          </a:p>
+        </p:txBody>
+      </p:sp>
+      <p:sp>
+        <p:nvSpPr>
+          <p:cNvPr id="16" name="TextBox 15"/>
+          <p:cNvSpPr txBox="1"/>
+          <p:nvPr/>
+        </p:nvSpPr>
+        <p:spPr>
+          <a:xfrm>
+            <a:off x="2194560" y="4297680"/>
+            <a:ext cx="8229600" cy="548640"/>
+          </a:xfrm>
+          <a:prstGeom prst="rect">
+            <a:avLst/>
+          </a:prstGeom>
+          <a:noFill/>
+        </p:spPr>
+        <p:txBody>
+          <a:bodyPr wrap="square">
+            <a:spAutoFit/>
+          </a:bodyPr>
+          <a:lstStyle/>
+          <a:p>
+            <a:pPr>
+              <a:spcAft>
+                <a:spcPts val="600"/>
+              </a:spcAft>
+            </a:pPr>
+            <a:r>
+              <a:rPr sz="2400" b="0">
+                <a:latin typeface="Calibri"/>
+              </a:rPr>
+              <a:t>Work Done</a:t>
+            </a:r>
+          </a:p>
+        </p:txBody>
+      </p:sp>
+      <p:sp>
+        <p:nvSpPr>
+          <p:cNvPr id="17" name="TextBox 16"/>
+          <p:cNvSpPr txBox="1"/>
+          <p:nvPr/>
+        </p:nvSpPr>
+        <p:spPr>
+          <a:xfrm>
+            <a:off x="1097280" y="4919472"/>
+            <a:ext cx="914400" cy="548640"/>
+          </a:xfrm>
+          <a:prstGeom prst="rect">
+            <a:avLst/>
+          </a:prstGeom>
+          <a:noFill/>
+        </p:spPr>
+        <p:txBody>
+          <a:bodyPr wrap="square">
+            <a:spAutoFit/>
+          </a:bodyPr>
+          <a:lstStyle/>
+          <a:p>
+            <a:pPr>
+              <a:spcAft>
+                <a:spcPts val="600"/>
+              </a:spcAft>
+            </a:pPr>
+            <a:r>
+              <a:rPr sz="2400" b="1">
+                <a:solidFill>
+                  <a:srgbClr val="0072B2"/>
+                </a:solidFill>
+                <a:latin typeface="Calibri"/>
+              </a:rPr>
+              <a:t>07</a:t>
+            </a:r>
+          </a:p>
+        </p:txBody>
+      </p:sp>
+      <p:sp>
+        <p:nvSpPr>
+          <p:cNvPr id="18" name="TextBox 17"/>
+          <p:cNvSpPr txBox="1"/>
+          <p:nvPr/>
+        </p:nvSpPr>
+        <p:spPr>
+          <a:xfrm>
+            <a:off x="2194560" y="4919472"/>
+            <a:ext cx="8229600" cy="548640"/>
+          </a:xfrm>
+          <a:prstGeom prst="rect">
+            <a:avLst/>
+          </a:prstGeom>
+          <a:noFill/>
+        </p:spPr>
+        <p:txBody>
+          <a:bodyPr wrap="square">
+            <a:spAutoFit/>
+          </a:bodyPr>
+          <a:lstStyle/>
+          <a:p>
+            <a:pPr>
+              <a:spcAft>
+                <a:spcPts val="600"/>
+              </a:spcAft>
+            </a:pPr>
+            <a:r>
+              <a:rPr sz="2400" b="0">
+                <a:latin typeface="Calibri"/>
+              </a:rPr>
+              <a:t>Results</a:t>
+            </a:r>
+          </a:p>
+        </p:txBody>
+      </p:sp>
+      <p:sp>
+        <p:nvSpPr>
+          <p:cNvPr id="19" name="TextBox 18"/>
+          <p:cNvSpPr txBox="1"/>
+          <p:nvPr/>
+        </p:nvSpPr>
+        <p:spPr>
+          <a:xfrm>
+            <a:off x="1097280" y="5541264"/>
+            <a:ext cx="914400" cy="548640"/>
+          </a:xfrm>
+          <a:prstGeom prst="rect">
+            <a:avLst/>
+          </a:prstGeom>
+          <a:noFill/>
+        </p:spPr>
+        <p:txBody>
+          <a:bodyPr wrap="square">
+            <a:spAutoFit/>
+          </a:bodyPr>
+          <a:lstStyle/>
+          <a:p>
+            <a:pPr>
+              <a:spcAft>
+                <a:spcPts val="600"/>
+              </a:spcAft>
+            </a:pPr>
+            <a:r>
+              <a:rPr sz="2400" b="1">
+                <a:solidFill>
+                  <a:srgbClr val="0072B2"/>
+                </a:solidFill>
+                <a:latin typeface="Calibri"/>
+              </a:rPr>
+              <a:t>08</a:t>
+            </a:r>
+          </a:p>
+        </p:txBody>
+      </p:sp>
+      <p:sp>
+        <p:nvSpPr>
+          <p:cNvPr id="20" name="TextBox 19"/>
+          <p:cNvSpPr txBox="1"/>
+          <p:nvPr/>
+        </p:nvSpPr>
+        <p:spPr>
+          <a:xfrm>
+            <a:off x="2194560" y="5541264"/>
+            <a:ext cx="8229600" cy="548640"/>
+          </a:xfrm>
+          <a:prstGeom prst="rect">
+            <a:avLst/>
+          </a:prstGeom>
+          <a:noFill/>
+        </p:spPr>
+        <p:txBody>
+          <a:bodyPr wrap="square">
+            <a:spAutoFit/>
+          </a:bodyPr>
+          <a:lstStyle/>
+          <a:p>
+            <a:pPr>
+              <a:spcAft>
+                <a:spcPts val="600"/>
+              </a:spcAft>
+            </a:pPr>
+            <a:r>
+              <a:rPr sz="2400" b="0">
+                <a:latin typeface="Calibri"/>
+              </a:rPr>
+              <a:t>References</a:t>
+            </a:r>
+          </a:p>
+        </p:txBody>
+      </p:sp>
+      <p:sp>
+        <p:nvSpPr>
+          <p:cNvPr id="21" name="TextBox 20"/>
+          <p:cNvSpPr txBox="1"/>
+          <p:nvPr/>
+        </p:nvSpPr>
+        <p:spPr>
+          <a:xfrm>
+            <a:off x="1097280" y="6217920"/>
+            <a:ext cx="10058400" cy="457200"/>
+          </a:xfrm>
+          <a:prstGeom prst="rect">
+            <a:avLst/>
+          </a:prstGeom>
+          <a:noFill/>
+        </p:spPr>
+        <p:txBody>
+          <a:bodyPr wrap="square">
+            <a:spAutoFit/>
+          </a:bodyPr>
+          <a:lstStyle/>
+          <a:p>
+            <a:pPr>
+              <a:spcAft>
+                <a:spcPts val="600"/>
+              </a:spcAft>
+            </a:pPr>
+            <a:r>
+              <a:rPr sz="1400" b="0">
+                <a:solidFill>
+                  <a:srgbClr val="555555"/>
+                </a:solidFill>
+                <a:latin typeface="Calibri"/>
+              </a:rPr>
+              <a:t>Template matching of environmental sounds with normalised cross-correlation (ESC-50)</a:t>
+            </a:r>
+          </a:p>
+        </p:txBody>
+      </p:sp>
     </p:spTree>
   </p:cSld>
   <p:clrMapOvr>
@@ -3755,7 +4282,7 @@
                 </a:solidFill>
                 <a:latin typeface="Calibri"/>
               </a:rPr>
-              <a:t>2  Comparative Study of Literature</a:t>
+              <a:t>Comparative Study of Literature</a:t>
             </a:r>
           </a:p>
         </p:txBody>
@@ -3808,8 +4335,8 @@
           <p:nvPr/>
         </p:nvGraphicFramePr>
         <p:xfrm>
-          <a:off x="457200" y="1280160"/>
-          <a:ext cx="11247120" cy="4023360"/>
+          <a:off x="457200" y="1188720"/>
+          <a:ext cx="11247120" cy="4206240"/>
         </p:xfrm>
         <a:graphic>
           <a:graphicData uri="http://schemas.openxmlformats.org/drawingml/2006/table">
@@ -3822,14 +4349,14 @@
                 <a:gridCol w="1188720"/>
                 <a:gridCol w="4297680"/>
               </a:tblGrid>
-              <a:tr h="574765">
+              <a:tr h="525780">
                 <a:tc>
                   <a:txBody>
                     <a:bodyPr/>
                     <a:lstStyle/>
                     <a:p>
                       <a:r>
-                        <a:rPr sz="1600" b="1">
+                        <a:rPr sz="1400" b="1">
                           <a:solidFill>
                             <a:srgbClr val="FFFFFF"/>
                           </a:solidFill>
@@ -3851,7 +4378,7 @@
                     <a:lstStyle/>
                     <a:p>
                       <a:r>
-                        <a:rPr sz="1600" b="1">
+                        <a:rPr sz="1400" b="1">
                           <a:solidFill>
                             <a:srgbClr val="FFFFFF"/>
                           </a:solidFill>
@@ -3873,7 +4400,7 @@
                     <a:lstStyle/>
                     <a:p>
                       <a:r>
-                        <a:rPr sz="1600" b="1">
+                        <a:rPr sz="1400" b="1">
                           <a:solidFill>
                             <a:srgbClr val="FFFFFF"/>
                           </a:solidFill>
@@ -3890,23 +4417,17 @@
                   </a:tcPr>
                 </a:tc>
               </a:tr>
-              <a:tr h="574765">
+              <a:tr h="525780">
                 <a:tc>
                   <a:txBody>
                     <a:bodyPr/>
                     <a:lstStyle/>
                     <a:p>
                       <a:r>
-                        <a:rPr sz="1600" b="0">
-                          <a:solidFill>
-                            <a:srgbClr val="000000"/>
-                          </a:solidFill>
+                        <a:rPr sz="1400" b="0">
                           <a:latin typeface="Calibri"/>
-                          <a:highlight>
-                            <a:srgbClr val="FFFF00"/>
-                          </a:highlight>
                         </a:rPr>
-                        <a:t>[Base paper to be verified by the student]</a:t>
+                        <a:t>BASE PAPER: Nolasco et al., Learning to detect an animal sound from five examples, Ecological Informatics [17]</a:t>
                       </a:r>
                     </a:p>
                   </a:txBody>
@@ -3922,10 +4443,10 @@
                     <a:lstStyle/>
                     <a:p>
                       <a:r>
-                        <a:rPr sz="1600" b="0">
+                        <a:rPr sz="1400" b="0">
                           <a:latin typeface="Calibri"/>
                         </a:rPr>
-                        <a:t>[Year]</a:t>
+                        <a:t>2023</a:t>
                       </a:r>
                     </a:p>
                   </a:txBody>
@@ -3941,10 +4462,10 @@
                     <a:lstStyle/>
                     <a:p>
                       <a:r>
-                        <a:rPr sz="1600" b="0">
+                        <a:rPr sz="1400" b="0">
                           <a:latin typeface="Calibri"/>
                         </a:rPr>
-                        <a:t>[Not verified within the time limit]</a:t>
+                        <a:t>Detect a sound from few examples; template matching is the classic baseline</a:t>
                       </a:r>
                     </a:p>
                   </a:txBody>
@@ -3955,17 +4476,17 @@
                   </a:tcPr>
                 </a:tc>
               </a:tr>
-              <a:tr h="574765">
+              <a:tr h="525780">
                 <a:tc>
                   <a:txBody>
                     <a:bodyPr/>
                     <a:lstStyle/>
                     <a:p>
                       <a:r>
-                        <a:rPr sz="1600" b="0">
+                        <a:rPr sz="1400" b="0">
                           <a:latin typeface="Calibri"/>
                         </a:rPr>
-                        <a:t>Piczak, ESC dataset [1], [2]</a:t>
+                        <a:t>Tutul, Buchem, Pinkwart, cross-correlation vs CNN sound detection (arXiv preprint) [18]</a:t>
                       </a:r>
                     </a:p>
                   </a:txBody>
@@ -3981,10 +4502,10 @@
                     <a:lstStyle/>
                     <a:p>
                       <a:r>
-                        <a:rPr sz="1600" b="0">
+                        <a:rPr sz="1400" b="0">
                           <a:latin typeface="Calibri"/>
                         </a:rPr>
-                        <a:t>2015</a:t>
+                        <a:t>2026</a:t>
                       </a:r>
                     </a:p>
                   </a:txBody>
@@ -4000,10 +4521,10 @@
                     <a:lstStyle/>
                     <a:p>
                       <a:r>
-                        <a:rPr sz="1600" b="0">
+                        <a:rPr sz="1400" b="0">
                           <a:latin typeface="Calibri"/>
                         </a:rPr>
-                        <a:t>Labelled clips, 50 classes; benchmark data used here</a:t>
+                        <a:t>NCC with a fixed threshold detects a stored sound</a:t>
                       </a:r>
                     </a:p>
                   </a:txBody>
@@ -4014,17 +4535,17 @@
                   </a:tcPr>
                 </a:tc>
               </a:tr>
-              <a:tr h="574765">
+              <a:tr h="525780">
                 <a:tc>
                   <a:txBody>
                     <a:bodyPr/>
                     <a:lstStyle/>
                     <a:p>
                       <a:r>
-                        <a:rPr sz="1600" b="0">
+                        <a:rPr sz="1400" b="0">
                           <a:latin typeface="Calibri"/>
                         </a:rPr>
-                        <a:t>Richards, Fundamentals of Radar Signal Processing [4]</a:t>
+                        <a:t>Piczak, ESC dataset [1], [2]</a:t>
                       </a:r>
                     </a:p>
                   </a:txBody>
@@ -4040,10 +4561,10 @@
                     <a:lstStyle/>
                     <a:p>
                       <a:r>
-                        <a:rPr sz="1600" b="0">
+                        <a:rPr sz="1400" b="0">
                           <a:latin typeface="Calibri"/>
                         </a:rPr>
-                        <a:t>2014</a:t>
+                        <a:t>2015</a:t>
                       </a:r>
                     </a:p>
                   </a:txBody>
@@ -4059,10 +4580,10 @@
                     <a:lstStyle/>
                     <a:p>
                       <a:r>
-                        <a:rPr sz="1600" b="0">
+                        <a:rPr sz="1400" b="0">
                           <a:latin typeface="Calibri"/>
                         </a:rPr>
-                        <a:t>Matched filter and correlation detection</a:t>
+                        <a:t>Labelled clips, 50 classes; data used here</a:t>
                       </a:r>
                     </a:p>
                   </a:txBody>
@@ -4073,17 +4594,17 @@
                   </a:tcPr>
                 </a:tc>
               </a:tr>
-              <a:tr h="574765">
+              <a:tr h="525780">
                 <a:tc>
                   <a:txBody>
                     <a:bodyPr/>
                     <a:lstStyle/>
                     <a:p>
                       <a:r>
-                        <a:rPr sz="1600" b="0">
+                        <a:rPr sz="1400" b="0">
                           <a:latin typeface="Calibri"/>
                         </a:rPr>
-                        <a:t>Richards, Scheer, Holm, Principles of Modern Radar [5]</a:t>
+                        <a:t>Richards, Fundamentals of Radar Signal Processing [4]</a:t>
                       </a:r>
                     </a:p>
                   </a:txBody>
@@ -4099,10 +4620,10 @@
                     <a:lstStyle/>
                     <a:p>
                       <a:r>
-                        <a:rPr sz="1600" b="0">
+                        <a:rPr sz="1400" b="0">
                           <a:latin typeface="Calibri"/>
                         </a:rPr>
-                        <a:t>2010</a:t>
+                        <a:t>2014</a:t>
                       </a:r>
                     </a:p>
                   </a:txBody>
@@ -4118,10 +4639,10 @@
                     <a:lstStyle/>
                     <a:p>
                       <a:r>
-                        <a:rPr sz="1600" b="0">
+                        <a:rPr sz="1400" b="0">
                           <a:latin typeface="Calibri"/>
                         </a:rPr>
-                        <a:t>Correlation detection and thresholds</a:t>
+                        <a:t>Matched filter and correlation detection</a:t>
                       </a:r>
                     </a:p>
                   </a:txBody>
@@ -4132,17 +4653,17 @@
                   </a:tcPr>
                 </a:tc>
               </a:tr>
-              <a:tr h="574765">
+              <a:tr h="525780">
                 <a:tc>
                   <a:txBody>
                     <a:bodyPr/>
                     <a:lstStyle/>
                     <a:p>
                       <a:r>
-                        <a:rPr sz="1600" b="0">
+                        <a:rPr sz="1400" b="0">
                           <a:latin typeface="Calibri"/>
                         </a:rPr>
-                        <a:t>Skolnik, Radar Handbook [6]</a:t>
+                        <a:t>Richards, Scheer, Holm, Principles of Modern Radar [5]</a:t>
                       </a:r>
                     </a:p>
                   </a:txBody>
@@ -4158,10 +4679,10 @@
                     <a:lstStyle/>
                     <a:p>
                       <a:r>
-                        <a:rPr sz="1600" b="0">
+                        <a:rPr sz="1400" b="0">
                           <a:latin typeface="Calibri"/>
                         </a:rPr>
-                        <a:t>2008</a:t>
+                        <a:t>2010</a:t>
                       </a:r>
                     </a:p>
                   </a:txBody>
@@ -4177,10 +4698,10 @@
                     <a:lstStyle/>
                     <a:p>
                       <a:r>
-                        <a:rPr sz="1600" b="0">
+                        <a:rPr sz="1400" b="0">
                           <a:latin typeface="Calibri"/>
                         </a:rPr>
-                        <a:t>Matched filtering reference</a:t>
+                        <a:t>Correlation detection and thresholds</a:t>
                       </a:r>
                     </a:p>
                   </a:txBody>
@@ -4191,17 +4712,17 @@
                   </a:tcPr>
                 </a:tc>
               </a:tr>
-              <a:tr h="574770">
+              <a:tr h="525780">
                 <a:tc>
                   <a:txBody>
                     <a:bodyPr/>
                     <a:lstStyle/>
                     <a:p>
                       <a:r>
-                        <a:rPr sz="1600" b="0">
+                        <a:rPr sz="1400" b="0">
                           <a:latin typeface="Calibri"/>
                         </a:rPr>
-                        <a:t>TU Berlin, Matched Filter and Pulse Compression [7]</a:t>
+                        <a:t>Skolnik, Radar Handbook [6]</a:t>
                       </a:r>
                     </a:p>
                   </a:txBody>
@@ -4217,10 +4738,10 @@
                     <a:lstStyle/>
                     <a:p>
                       <a:r>
-                        <a:rPr sz="1600" b="0">
+                        <a:rPr sz="1400" b="0">
                           <a:latin typeface="Calibri"/>
                         </a:rPr>
-                        <a:t>n.d.</a:t>
+                        <a:t>2008</a:t>
                       </a:r>
                     </a:p>
                   </a:txBody>
@@ -4236,10 +4757,10 @@
                     <a:lstStyle/>
                     <a:p>
                       <a:r>
-                        <a:rPr sz="1600" b="0">
+                        <a:rPr sz="1400" b="0">
                           <a:latin typeface="Calibri"/>
                         </a:rPr>
-                        <a:t>FFT correlation in Python</a:t>
+                        <a:t>Matched filtering reference</a:t>
                       </a:r>
                     </a:p>
                   </a:txBody>
@@ -4250,6 +4771,65 @@
                   </a:tcPr>
                 </a:tc>
               </a:tr>
+              <a:tr h="525780">
+                <a:tc>
+                  <a:txBody>
+                    <a:bodyPr/>
+                    <a:lstStyle/>
+                    <a:p>
+                      <a:r>
+                        <a:rPr sz="1400" b="0">
+                          <a:latin typeface="Calibri"/>
+                        </a:rPr>
+                        <a:t>TU Berlin, Matched Filter and Pulse Compression [7]</a:t>
+                      </a:r>
+                    </a:p>
+                  </a:txBody>
+                  <a:tcPr>
+                    <a:solidFill>
+                      <a:srgbClr val="EEF3F8"/>
+                    </a:solidFill>
+                  </a:tcPr>
+                </a:tc>
+                <a:tc>
+                  <a:txBody>
+                    <a:bodyPr/>
+                    <a:lstStyle/>
+                    <a:p>
+                      <a:r>
+                        <a:rPr sz="1400" b="0">
+                          <a:latin typeface="Calibri"/>
+                        </a:rPr>
+                        <a:t>n.d.</a:t>
+                      </a:r>
+                    </a:p>
+                  </a:txBody>
+                  <a:tcPr>
+                    <a:solidFill>
+                      <a:srgbClr val="EEF3F8"/>
+                    </a:solidFill>
+                  </a:tcPr>
+                </a:tc>
+                <a:tc>
+                  <a:txBody>
+                    <a:bodyPr/>
+                    <a:lstStyle/>
+                    <a:p>
+                      <a:r>
+                        <a:rPr sz="1400" b="0">
+                          <a:latin typeface="Calibri"/>
+                        </a:rPr>
+                        <a:t>FFT correlation in Python</a:t>
+                      </a:r>
+                    </a:p>
+                  </a:txBody>
+                  <a:tcPr>
+                    <a:solidFill>
+                      <a:srgbClr val="EEF3F8"/>
+                    </a:solidFill>
+                  </a:tcPr>
+                </a:tc>
+              </a:tr>
             </a:tbl>
           </a:graphicData>
         </a:graphic>
@@ -4262,8 +4842,8 @@
         </p:nvSpPr>
         <p:spPr>
           <a:xfrm>
-            <a:off x="457200" y="5577840"/>
-            <a:ext cx="10972800" cy="822960"/>
+            <a:off x="457200" y="5760720"/>
+            <a:ext cx="11247120" cy="822960"/>
           </a:xfrm>
           <a:prstGeom prst="rect">
             <a:avLst/>
@@ -4282,13 +4862,13 @@
               </a:spcAft>
             </a:pPr>
             <a:r>
-              <a:rPr sz="1400" b="0">
+              <a:rPr sz="1300" b="0">
                 <a:solidFill>
                   <a:srgbClr val="555555"/>
                 </a:solidFill>
                 <a:latin typeface="Calibri"/>
               </a:rPr>
-              <a:t>Base paper not verified (no access to check authors, year, venue, DOI) - left as a placeholder. Other rows are summaries, not full-text reviews.</a:t>
+              <a:t>Base paper: title, authors, journal and DOI checked against repository records; summarised from its abstract (full text not read). Latest-to-oldest after the base paper.</a:t>
             </a:r>
           </a:p>
         </p:txBody>
@@ -4388,7 +4968,7 @@
                 </a:solidFill>
                 <a:latin typeface="Calibri"/>
               </a:rPr>
-              <a:t>3  Objective</a:t>
+              <a:t>Objective</a:t>
             </a:r>
           </a:p>
         </p:txBody>
@@ -4440,8 +5020,85 @@
         </p:nvSpPr>
         <p:spPr>
           <a:xfrm>
+            <a:off x="7589520" y="1280160"/>
+            <a:ext cx="4297680" cy="4937760"/>
+          </a:xfrm>
+          <a:prstGeom prst="rect">
+            <a:avLst/>
+          </a:prstGeom>
+          <a:solidFill>
+            <a:srgbClr val="EEF3F8"/>
+          </a:solidFill>
+        </p:spPr>
+        <p:txBody>
+          <a:bodyPr wrap="square">
+            <a:spAutoFit/>
+          </a:bodyPr>
+          <a:lstStyle/>
+          <a:p>
+            <a:pPr>
+              <a:spcAft>
+                <a:spcPts val="600"/>
+              </a:spcAft>
+            </a:pPr>
+            <a:r>
+              <a:rPr sz="1500" b="0">
+                <a:latin typeface="Calibri"/>
+              </a:rPr>
+              <a:t>Background</a:t>
+            </a:r>
+          </a:p>
+          <a:p>
+            <a:pPr>
+              <a:spcAft>
+                <a:spcPts val="600"/>
+              </a:spcAft>
+            </a:pPr>
+            <a:r>
+              <a:rPr sz="1500" b="0">
+                <a:latin typeface="Calibri"/>
+              </a:rPr>
+              <a:t>Template matching = slide a known sound along a recording and score every position (NCC [4], [7])</a:t>
+            </a:r>
+          </a:p>
+          <a:p>
+            <a:pPr>
+              <a:spcAft>
+                <a:spcPts val="600"/>
+              </a:spcAft>
+            </a:pPr>
+            <a:r>
+              <a:rPr sz="1500" b="0">
+                <a:latin typeface="Calibri"/>
+              </a:rPr>
+              <a:t>Test data: ESC-50 [1], [2] clips joined with 1 s silences, so true positions are known</a:t>
+            </a:r>
+          </a:p>
+          <a:p>
+            <a:pPr>
+              <a:spcAft>
+                <a:spcPts val="600"/>
+              </a:spcAft>
+            </a:pPr>
+            <a:r>
+              <a:rPr sz="1500" b="0">
+                <a:latin typeface="Calibri"/>
+              </a:rPr>
+              <a:t>CC BY-NC 3.0 [3]; 5 classes, 16 kHz</a:t>
+            </a:r>
+          </a:p>
+        </p:txBody>
+      </p:sp>
+      <p:sp>
+        <p:nvSpPr>
+          <p:cNvPr id="6" name="TextBox 5"/>
+          <p:cNvSpPr txBox="1"/>
+          <p:nvPr/>
+        </p:nvSpPr>
+        <p:spPr>
+          <a:xfrm>
             <a:off x="548640" y="1280160"/>
-            <a:ext cx="10972800" cy="4937760"/>
+            <a:ext cx="6858000" cy="4937760"/>
           </a:xfrm>
           <a:prstGeom prst="rect">
             <a:avLst/>
@@ -4460,7 +5117,7 @@
               </a:spcAft>
             </a:pPr>
             <a:r>
-              <a:rPr sz="2200" b="0">
+              <a:rPr sz="1800" b="0">
                 <a:latin typeface="Calibri"/>
               </a:rPr>
               <a:t>•  Load ESC-50, convert to mono 16 kHz, normalise</a:t>
@@ -4473,7 +5130,7 @@
               </a:spcAft>
             </a:pPr>
             <a:r>
-              <a:rPr sz="2200" b="0">
+              <a:rPr sz="1800" b="0">
                 <a:latin typeface="Calibri"/>
               </a:rPr>
               <a:t>•  Join clips with 1 s silences; record exact spans as ground truth</a:t>
@@ -4486,7 +5143,7 @@
               </a:spcAft>
             </a:pPr>
             <a:r>
-              <a:rPr sz="2200" b="0">
+              <a:rPr sz="1800" b="0">
                 <a:latin typeface="Calibri"/>
               </a:rPr>
               <a:t>•  FFT-based normalised cross-correlation in NumPy; threshold + non-maximum suppression</a:t>
@@ -4499,7 +5156,7 @@
               </a:spcAft>
             </a:pPr>
             <a:r>
-              <a:rPr sz="2200" b="0">
+              <a:rPr sz="1800" b="0">
                 <a:latin typeface="Calibri"/>
               </a:rPr>
               <a:t>•  Detection correct if its centre lies inside a true clip; precision, recall, F1</a:t>
@@ -4512,7 +5169,7 @@
               </a:spcAft>
             </a:pPr>
             <a:r>
-              <a:rPr sz="2200" b="0">
+              <a:rPr sz="1800" b="0">
                 <a:latin typeface="Calibri"/>
               </a:rPr>
               <a:t>•  Streamlit app with a threshold slider and plots</a:t>
@@ -4525,7 +5182,7 @@
               </a:spcAft>
             </a:pPr>
             <a:r>
-              <a:rPr sz="2200" b="0">
+              <a:rPr sz="1800" b="0">
                 <a:latin typeface="Calibri"/>
               </a:rPr>
               <a:t>•  Experiment: P/R/F1 vs threshold, 5 classes, 30 recordings each; best threshold per class</a:t>
@@ -4628,7 +5285,7 @@
                 </a:solidFill>
                 <a:latin typeface="Calibri"/>
               </a:rPr>
-              <a:t>4  Methodology</a:t>
+              <a:t>Methodology (Flow Chart)</a:t>
             </a:r>
           </a:p>
         </p:txBody>
@@ -4840,7 +5497,7 @@
                 </a:solidFill>
                 <a:latin typeface="Calibri"/>
               </a:rPr>
-              <a:t>5  Work Done</a:t>
+              <a:t>Work Done</a:t>
             </a:r>
           </a:p>
         </p:txBody>
@@ -5091,7 +5748,7 @@
                 </a:solidFill>
                 <a:latin typeface="Calibri"/>
               </a:rPr>
-              <a:t>6  Results</a:t>
+              <a:t>Results</a:t>
             </a:r>
           </a:p>
         </p:txBody>
@@ -5329,7 +5986,7 @@
                 </a:solidFill>
                 <a:latin typeface="Calibri"/>
               </a:rPr>
-              <a:t>7  References</a:t>
+              <a:t>References</a:t>
             </a:r>
           </a:p>
         </p:txBody>
@@ -5401,7 +6058,33 @@
               </a:spcAft>
             </a:pPr>
             <a:r>
-              <a:rPr sz="1400" b="0">
+              <a:rPr sz="1200" b="0">
+                <a:latin typeface="Calibri"/>
+              </a:rPr>
+              <a:t>[17] I. Nolasco, S. Singh, V. Morfi, V. Lostanlen, A. Strandburg-Peshkin, E. Vidana-Vila, L. Gill, H. Pamula, H. Whitehead, I. Kiskin, F. H. Jensen, J. Morford, M. G. Emmerson, E. Versace, E. Grout, H. Liu, B. Ghani and D. Stowell, "Learning to detect an animal sound from five examples", Ecological Informatics, vol. 77, art. 102258, 2023, doi:10.1016/j.ecoinf.2023.102258 (BASE PAPER; also on arXiv:2305.13210).</a:t>
+            </a:r>
+          </a:p>
+          <a:p>
+            <a:pPr>
+              <a:spcAft>
+                <a:spcPts val="600"/>
+              </a:spcAft>
+            </a:pPr>
+            <a:r>
+              <a:rPr sz="1200" b="0">
+                <a:latin typeface="Calibri"/>
+              </a:rPr>
+              <a:t>[18] R. Tutul, I. Buchem and N. Pinkwart, "Algorithmic Accuracy as a Motivational Driver in Robot-Mediated Learning: A Comparative Study of Cross-Correlation and CNN-Based Sound Detection in an Interactive Quiz Game", arXiv:2607.16299, July 2026 (preprint).</a:t>
+            </a:r>
+          </a:p>
+          <a:p>
+            <a:pPr>
+              <a:spcAft>
+                <a:spcPts val="600"/>
+              </a:spcAft>
+            </a:pPr>
+            <a:r>
+              <a:rPr sz="1200" b="0">
                 <a:latin typeface="Calibri"/>
               </a:rPr>
               <a:t>[1] K. J. Piczak, "ESC: Dataset for Environmental Sound Classification", Proc. 23rd ACM International Conference on Multimedia (ACM Multimedia), 2015.</a:t>
@@ -5414,7 +6097,7 @@
               </a:spcAft>
             </a:pPr>
             <a:r>
-              <a:rPr sz="1400" b="0">
+              <a:rPr sz="1200" b="0">
                 <a:latin typeface="Calibri"/>
               </a:rPr>
               <a:t>[2] K. J. Piczak, ESC-50: Dataset for Environmental Sound Classification (2,000 clips, 50 classes), github.com/karolpiczak/ESC-50.</a:t>
@@ -5427,7 +6110,7 @@
               </a:spcAft>
             </a:pPr>
             <a:r>
-              <a:rPr sz="1400" b="0">
+              <a:rPr sz="1200" b="0">
                 <a:latin typeface="Calibri"/>
               </a:rPr>
               <a:t>[3] Creative Commons Attribution-NonCommercial 3.0 licence (CC BY-NC 3.0), creativecommons.org/licenses/by-nc/3.0/.</a:t>
@@ -5440,7 +6123,7 @@
               </a:spcAft>
             </a:pPr>
             <a:r>
-              <a:rPr sz="1400" b="0">
+              <a:rPr sz="1200" b="0">
                 <a:latin typeface="Calibri"/>
               </a:rPr>
               <a:t>[4] M. A. Richards, Fundamentals of Radar Signal Processing, 2nd ed., McGraw-Hill, 2014.</a:t>
@@ -5453,48 +6136,10 @@
               </a:spcAft>
             </a:pPr>
             <a:r>
-              <a:rPr sz="1400" b="0">
-                <a:latin typeface="Calibri"/>
-              </a:rPr>
-              <a:t>[5] M. A. Richards, J. A. Scheer and W. A. Holm (eds.), Principles of Modern Radar: Basic Principles, SciTech Publishing, 2010.</a:t>
-            </a:r>
-          </a:p>
-          <a:p>
-            <a:pPr>
-              <a:spcAft>
-                <a:spcPts val="600"/>
-              </a:spcAft>
-            </a:pPr>
-            <a:r>
-              <a:rPr sz="1400" b="0">
+              <a:rPr sz="1200" b="0">
                 <a:latin typeface="Calibri"/>
               </a:rPr>
               <a:t>[7] TU Berlin, "Matched Filter and Pulse Compression", chapter of the Scientific Python course, platform.commit.tu-berlin.de/en/book/sci-python/chapter/ch25/section/s01.</a:t>
-            </a:r>
-          </a:p>
-          <a:p>
-            <a:pPr>
-              <a:spcAft>
-                <a:spcPts val="600"/>
-              </a:spcAft>
-            </a:pPr>
-            <a:r>
-              <a:rPr sz="1400" b="0">
-                <a:latin typeface="Calibri"/>
-              </a:rPr>
-              <a:t>Base paper: </a:t>
-            </a:r>
-            <a:r>
-              <a:rPr sz="1400" b="0">
-                <a:solidFill>
-                  <a:srgbClr val="000000"/>
-                </a:solidFill>
-                <a:latin typeface="Calibri"/>
-                <a:highlight>
-                  <a:srgbClr val="FFFF00"/>
-                </a:highlight>
-              </a:rPr>
-              <a:t>[Base paper to be verified by the student]</a:t>
             </a:r>
           </a:p>
         </p:txBody>
@@ -5533,7 +6178,7 @@
                 </a:solidFill>
                 <a:latin typeface="Calibri"/>
               </a:rPr>
-              <a:t>Full list of 16 references in the report.</a:t>
+              <a:t>Full list of 18 references in the report. [17] is the base paper.</a:t>
             </a:r>
           </a:p>
         </p:txBody>

</xml_diff>

<commit_message>
Base paper is now the 2026 Tutul et al. preprint; literature study limited to 2020+ papers, latest to oldest
Co-Authored-By: Claude Sonnet 5.5 <noreply@anthropic.com>
Claude-Session: https://claude.ai/code/session_012DKUQj8phYpnuRrxK5eNsm
</commit_message>
<xml_diff>
--- a/esc50_matching/docs/presentation.pptx
+++ b/esc50_matching/docs/presentation.pptx
@@ -4349,7 +4349,7 @@
                 <a:gridCol w="1188720"/>
                 <a:gridCol w="4297680"/>
               </a:tblGrid>
-              <a:tr h="525780">
+              <a:tr h="701040">
                 <a:tc>
                   <a:txBody>
                     <a:bodyPr/>
@@ -4417,7 +4417,7 @@
                   </a:tcPr>
                 </a:tc>
               </a:tr>
-              <a:tr h="525780">
+              <a:tr h="701040">
                 <a:tc>
                   <a:txBody>
                     <a:bodyPr/>
@@ -4427,7 +4427,7 @@
                         <a:rPr sz="1400" b="0">
                           <a:latin typeface="Calibri"/>
                         </a:rPr>
-                        <a:t>BASE PAPER: Nolasco et al., Learning to detect an animal sound from five examples, Ecological Informatics [17]</a:t>
+                        <a:t>BASE PAPER: Tutul, Buchem, Pinkwart, cross-correlation vs CNN sound detection (arXiv preprint) [1]</a:t>
                       </a:r>
                     </a:p>
                   </a:txBody>
@@ -4446,7 +4446,7 @@
                         <a:rPr sz="1400" b="0">
                           <a:latin typeface="Calibri"/>
                         </a:rPr>
-                        <a:t>2023</a:t>
+                        <a:t>2026</a:t>
                       </a:r>
                     </a:p>
                   </a:txBody>
@@ -4465,7 +4465,7 @@
                         <a:rPr sz="1400" b="0">
                           <a:latin typeface="Calibri"/>
                         </a:rPr>
-                        <a:t>Detect a sound from few examples; template matching is the classic baseline</a:t>
+                        <a:t>Normalised cross-correlation + fixed threshold detects a stored sound, no training</a:t>
                       </a:r>
                     </a:p>
                   </a:txBody>
@@ -4476,7 +4476,7 @@
                   </a:tcPr>
                 </a:tc>
               </a:tr>
-              <a:tr h="525780">
+              <a:tr h="701040">
                 <a:tc>
                   <a:txBody>
                     <a:bodyPr/>
@@ -4486,7 +4486,7 @@
                         <a:rPr sz="1400" b="0">
                           <a:latin typeface="Calibri"/>
                         </a:rPr>
-                        <a:t>Tutul, Buchem, Pinkwart, cross-correlation vs CNN sound detection (arXiv preprint) [18]</a:t>
+                        <a:t>Nolasco et al., Learning to detect an animal sound from five examples, Ecol. Informatics [2]</a:t>
                       </a:r>
                     </a:p>
                   </a:txBody>
@@ -4505,7 +4505,7 @@
                         <a:rPr sz="1400" b="0">
                           <a:latin typeface="Calibri"/>
                         </a:rPr>
-                        <a:t>2026</a:t>
+                        <a:t>2023</a:t>
                       </a:r>
                     </a:p>
                   </a:txBody>
@@ -4524,7 +4524,7 @@
                         <a:rPr sz="1400" b="0">
                           <a:latin typeface="Calibri"/>
                         </a:rPr>
-                        <a:t>NCC with a fixed threshold detects a stored sound</a:t>
+                        <a:t>Few-shot detection; template matching is the traditional baseline</a:t>
                       </a:r>
                     </a:p>
                   </a:txBody>
@@ -4535,7 +4535,7 @@
                   </a:tcPr>
                 </a:tc>
               </a:tr>
-              <a:tr h="525780">
+              <a:tr h="701040">
                 <a:tc>
                   <a:txBody>
                     <a:bodyPr/>
@@ -4545,7 +4545,7 @@
                         <a:rPr sz="1400" b="0">
                           <a:latin typeface="Calibri"/>
                         </a:rPr>
-                        <a:t>Piczak, ESC dataset [1], [2]</a:t>
+                        <a:t>Nolasco et al., Few-shot bioacoustic event detection, DCASE 2022 [3]</a:t>
                       </a:r>
                     </a:p>
                   </a:txBody>
@@ -4564,7 +4564,7 @@
                         <a:rPr sz="1400" b="0">
                           <a:latin typeface="Calibri"/>
                         </a:rPr>
-                        <a:t>2015</a:t>
+                        <a:t>2022</a:t>
                       </a:r>
                     </a:p>
                   </a:txBody>
@@ -4583,7 +4583,7 @@
                         <a:rPr sz="1400" b="0">
                           <a:latin typeface="Calibri"/>
                         </a:rPr>
-                        <a:t>Labelled clips, 50 classes; data used here</a:t>
+                        <a:t>Challenge overview; detecting a sound from few examples is still open</a:t>
                       </a:r>
                     </a:p>
                   </a:txBody>
@@ -4594,7 +4594,7 @@
                   </a:tcPr>
                 </a:tc>
               </a:tr>
-              <a:tr h="525780">
+              <a:tr h="701040">
                 <a:tc>
                   <a:txBody>
                     <a:bodyPr/>
@@ -4604,7 +4604,7 @@
                         <a:rPr sz="1400" b="0">
                           <a:latin typeface="Calibri"/>
                         </a:rPr>
-                        <a:t>Richards, Fundamentals of Radar Signal Processing [4]</a:t>
+                        <a:t>Gong, Chung, Glass, AST: Audio Spectrogram Transformer, Interspeech [4]</a:t>
                       </a:r>
                     </a:p>
                   </a:txBody>
@@ -4623,7 +4623,7 @@
                         <a:rPr sz="1400" b="0">
                           <a:latin typeface="Calibri"/>
                         </a:rPr>
-                        <a:t>2014</a:t>
+                        <a:t>2021</a:t>
                       </a:r>
                     </a:p>
                   </a:txBody>
@@ -4642,7 +4642,7 @@
                         <a:rPr sz="1400" b="0">
                           <a:latin typeface="Calibri"/>
                         </a:rPr>
-                        <a:t>Matched filter and correlation detection</a:t>
+                        <a:t>Learned classifier on spectrograms; reports 95.6 % on ESC-50</a:t>
                       </a:r>
                     </a:p>
                   </a:txBody>
@@ -4653,7 +4653,7 @@
                   </a:tcPr>
                 </a:tc>
               </a:tr>
-              <a:tr h="525780">
+              <a:tr h="701040">
                 <a:tc>
                   <a:txBody>
                     <a:bodyPr/>
@@ -4663,7 +4663,7 @@
                         <a:rPr sz="1400" b="0">
                           <a:latin typeface="Calibri"/>
                         </a:rPr>
-                        <a:t>Richards, Scheer, Holm, Principles of Modern Radar [5]</a:t>
+                        <a:t>Kong et al., PANNs, IEEE/ACM TASLP [5]</a:t>
                       </a:r>
                     </a:p>
                   </a:txBody>
@@ -4682,7 +4682,7 @@
                         <a:rPr sz="1400" b="0">
                           <a:latin typeface="Calibri"/>
                         </a:rPr>
-                        <a:t>2010</a:t>
+                        <a:t>2020</a:t>
                       </a:r>
                     </a:p>
                   </a:txBody>
@@ -4701,125 +4701,7 @@
                         <a:rPr sz="1400" b="0">
                           <a:latin typeface="Calibri"/>
                         </a:rPr>
-                        <a:t>Correlation detection and thresholds</a:t>
-                      </a:r>
-                    </a:p>
-                  </a:txBody>
-                  <a:tcPr>
-                    <a:solidFill>
-                      <a:srgbClr val="EEF3F8"/>
-                    </a:solidFill>
-                  </a:tcPr>
-                </a:tc>
-              </a:tr>
-              <a:tr h="525780">
-                <a:tc>
-                  <a:txBody>
-                    <a:bodyPr/>
-                    <a:lstStyle/>
-                    <a:p>
-                      <a:r>
-                        <a:rPr sz="1400" b="0">
-                          <a:latin typeface="Calibri"/>
-                        </a:rPr>
-                        <a:t>Skolnik, Radar Handbook [6]</a:t>
-                      </a:r>
-                    </a:p>
-                  </a:txBody>
-                  <a:tcPr>
-                    <a:solidFill>
-                      <a:srgbClr val="FFFFFF"/>
-                    </a:solidFill>
-                  </a:tcPr>
-                </a:tc>
-                <a:tc>
-                  <a:txBody>
-                    <a:bodyPr/>
-                    <a:lstStyle/>
-                    <a:p>
-                      <a:r>
-                        <a:rPr sz="1400" b="0">
-                          <a:latin typeface="Calibri"/>
-                        </a:rPr>
-                        <a:t>2008</a:t>
-                      </a:r>
-                    </a:p>
-                  </a:txBody>
-                  <a:tcPr>
-                    <a:solidFill>
-                      <a:srgbClr val="FFFFFF"/>
-                    </a:solidFill>
-                  </a:tcPr>
-                </a:tc>
-                <a:tc>
-                  <a:txBody>
-                    <a:bodyPr/>
-                    <a:lstStyle/>
-                    <a:p>
-                      <a:r>
-                        <a:rPr sz="1400" b="0">
-                          <a:latin typeface="Calibri"/>
-                        </a:rPr>
-                        <a:t>Matched filtering reference</a:t>
-                      </a:r>
-                    </a:p>
-                  </a:txBody>
-                  <a:tcPr>
-                    <a:solidFill>
-                      <a:srgbClr val="FFFFFF"/>
-                    </a:solidFill>
-                  </a:tcPr>
-                </a:tc>
-              </a:tr>
-              <a:tr h="525780">
-                <a:tc>
-                  <a:txBody>
-                    <a:bodyPr/>
-                    <a:lstStyle/>
-                    <a:p>
-                      <a:r>
-                        <a:rPr sz="1400" b="0">
-                          <a:latin typeface="Calibri"/>
-                        </a:rPr>
-                        <a:t>TU Berlin, Matched Filter and Pulse Compression [7]</a:t>
-                      </a:r>
-                    </a:p>
-                  </a:txBody>
-                  <a:tcPr>
-                    <a:solidFill>
-                      <a:srgbClr val="EEF3F8"/>
-                    </a:solidFill>
-                  </a:tcPr>
-                </a:tc>
-                <a:tc>
-                  <a:txBody>
-                    <a:bodyPr/>
-                    <a:lstStyle/>
-                    <a:p>
-                      <a:r>
-                        <a:rPr sz="1400" b="0">
-                          <a:latin typeface="Calibri"/>
-                        </a:rPr>
-                        <a:t>n.d.</a:t>
-                      </a:r>
-                    </a:p>
-                  </a:txBody>
-                  <a:tcPr>
-                    <a:solidFill>
-                      <a:srgbClr val="EEF3F8"/>
-                    </a:solidFill>
-                  </a:tcPr>
-                </a:tc>
-                <a:tc>
-                  <a:txBody>
-                    <a:bodyPr/>
-                    <a:lstStyle/>
-                    <a:p>
-                      <a:r>
-                        <a:rPr sz="1400" b="0">
-                          <a:latin typeface="Calibri"/>
-                        </a:rPr>
-                        <a:t>FFT correlation in Python</a:t>
+                        <a:t>Pretrained audio networks transfer to other tasks</a:t>
                       </a:r>
                     </a:p>
                   </a:txBody>
@@ -4868,7 +4750,7 @@
                 </a:solidFill>
                 <a:latin typeface="Calibri"/>
               </a:rPr>
-              <a:t>Base paper: title, authors, journal and DOI checked against repository records; summarised from its abstract (full text not read). Latest-to-oldest after the base paper.</a:t>
+              <a:t>Base paper: arXiv:2607.16299 (July 2026, open-access preprint), checked against its listing; summarised from the abstract only. All papers 2020 or later, latest to oldest.</a:t>
             </a:r>
           </a:p>
         </p:txBody>
@@ -5058,7 +4940,7 @@
               <a:rPr sz="1500" b="0">
                 <a:latin typeface="Calibri"/>
               </a:rPr>
-              <a:t>Template matching = slide a known sound along a recording and score every position (NCC [4], [7])</a:t>
+              <a:t>Template matching = slide a known sound along a recording and score every position (NCC [1], [2])</a:t>
             </a:r>
           </a:p>
           <a:p>
@@ -5071,7 +4953,7 @@
               <a:rPr sz="1500" b="0">
                 <a:latin typeface="Calibri"/>
               </a:rPr>
-              <a:t>Test data: ESC-50 [1], [2] clips joined with 1 s silences, so true positions are known</a:t>
+              <a:t>Test data: ESC-50 [6], [7] clips joined with 1 s silences, so true positions are known</a:t>
             </a:r>
           </a:p>
           <a:p>
@@ -5084,7 +4966,7 @@
               <a:rPr sz="1500" b="0">
                 <a:latin typeface="Calibri"/>
               </a:rPr>
-              <a:t>CC BY-NC 3.0 [3]; 5 classes, 16 kHz</a:t>
+              <a:t>CC BY-NC 3.0 [8]; 5 classes, 16 kHz</a:t>
             </a:r>
           </a:p>
         </p:txBody>
@@ -5572,7 +5454,7 @@
               <a:rPr sz="1800" b="0">
                 <a:latin typeface="Calibri"/>
               </a:rPr>
-              <a:t>•  NumPy [8] for all matching; SciPy [9] only for WAV reading and resampling</a:t>
+              <a:t>•  NumPy [10] for all matching; SciPy [11] only for WAV reading and resampling</a:t>
             </a:r>
           </a:p>
           <a:p>
@@ -5598,7 +5480,7 @@
               <a:rPr sz="1800" b="0">
                 <a:latin typeface="Calibri"/>
               </a:rPr>
-              <a:t>•  Streamlit app [11]; Matplotlib [10]</a:t>
+              <a:t>•  Streamlit app [13]; Matplotlib [12]</a:t>
             </a:r>
           </a:p>
           <a:p>
@@ -5611,7 +5493,7 @@
               <a:rPr sz="1800" b="0">
                 <a:latin typeface="Calibri"/>
               </a:rPr>
-              <a:t>•  pytest [12]: 6 tests, all pass</a:t>
+              <a:t>•  pytest [14]: 6 tests, all pass</a:t>
             </a:r>
           </a:p>
           <a:p>
@@ -6061,7 +5943,7 @@
               <a:rPr sz="1200" b="0">
                 <a:latin typeface="Calibri"/>
               </a:rPr>
-              <a:t>[17] I. Nolasco, S. Singh, V. Morfi, V. Lostanlen, A. Strandburg-Peshkin, E. Vidana-Vila, L. Gill, H. Pamula, H. Whitehead, I. Kiskin, F. H. Jensen, J. Morford, M. G. Emmerson, E. Versace, E. Grout, H. Liu, B. Ghani and D. Stowell, "Learning to detect an animal sound from five examples", Ecological Informatics, vol. 77, art. 102258, 2023, doi:10.1016/j.ecoinf.2023.102258 (BASE PAPER; also on arXiv:2305.13210).</a:t>
+              <a:t>[1] R. Tutul, I. Buchem and N. Pinkwart, "Algorithmic Accuracy as a Motivational Driver in Robot-Mediated Learning: A Comparative Study of Cross-Correlation and CNN-Based Sound Detection in an Interactive Quiz Game", arXiv:2607.16299, July 2026 (open-access preprint; BASE PAPER).</a:t>
             </a:r>
           </a:p>
           <a:p>
@@ -6074,7 +5956,7 @@
               <a:rPr sz="1200" b="0">
                 <a:latin typeface="Calibri"/>
               </a:rPr>
-              <a:t>[18] R. Tutul, I. Buchem and N. Pinkwart, "Algorithmic Accuracy as a Motivational Driver in Robot-Mediated Learning: A Comparative Study of Cross-Correlation and CNN-Based Sound Detection in an Interactive Quiz Game", arXiv:2607.16299, July 2026 (preprint).</a:t>
+              <a:t>[2] I. Nolasco, S. Singh, V. Morfi, V. Lostanlen, A. Strandburg-Peshkin, E. Vidana-Vila, L. Gill, H. Pamula, H. Whitehead, I. Kiskin, F. H. Jensen, J. Morford, M. G. Emmerson, E. Versace, E. Grout, H. Liu, B. Ghani and D. Stowell, "Learning to detect an animal sound from five examples", Ecological Informatics, vol. 77, art. 102258, 2023, doi:10.1016/j.ecoinf.2023.102258 (also arXiv:2305.13210).</a:t>
             </a:r>
           </a:p>
           <a:p>
@@ -6087,7 +5969,7 @@
               <a:rPr sz="1200" b="0">
                 <a:latin typeface="Calibri"/>
               </a:rPr>
-              <a:t>[1] K. J. Piczak, "ESC: Dataset for Environmental Sound Classification", Proc. 23rd ACM International Conference on Multimedia (ACM Multimedia), 2015.</a:t>
+              <a:t>[3] I. Nolasco et al., "Few-shot bioacoustic event detection at the DCASE 2022 challenge", arXiv preprint, July 2022.</a:t>
             </a:r>
           </a:p>
           <a:p>
@@ -6100,7 +5982,7 @@
               <a:rPr sz="1200" b="0">
                 <a:latin typeface="Calibri"/>
               </a:rPr>
-              <a:t>[2] K. J. Piczak, ESC-50: Dataset for Environmental Sound Classification (2,000 clips, 50 classes), github.com/karolpiczak/ESC-50.</a:t>
+              <a:t>[4] Y. Gong, Y.-A. Chung and J. Glass, "AST: Audio Spectrogram Transformer", Proc. Interspeech, 2021, arXiv:2104.01778.</a:t>
             </a:r>
           </a:p>
           <a:p>
@@ -6113,7 +5995,7 @@
               <a:rPr sz="1200" b="0">
                 <a:latin typeface="Calibri"/>
               </a:rPr>
-              <a:t>[3] Creative Commons Attribution-NonCommercial 3.0 licence (CC BY-NC 3.0), creativecommons.org/licenses/by-nc/3.0/.</a:t>
+              <a:t>[5] Q. Kong, Y. Cao, T. Iqbal, Y. Wang, W. Wang and M. D. Plumbley, "PANNs: Large-Scale Pretrained Audio Neural Networks for Audio Pattern Recognition", IEEE/ACM Trans. Audio, Speech, and Language Processing, vol. 28, pp. 2880-2894, 2020, doi:10.1109/TASLP.2020.3030497.</a:t>
             </a:r>
           </a:p>
           <a:p>
@@ -6126,7 +6008,7 @@
               <a:rPr sz="1200" b="0">
                 <a:latin typeface="Calibri"/>
               </a:rPr>
-              <a:t>[4] M. A. Richards, Fundamentals of Radar Signal Processing, 2nd ed., McGraw-Hill, 2014.</a:t>
+              <a:t>[6] K. J. Piczak, "ESC: Dataset for Environmental Sound Classification", Proc. 23rd ACM International Conference on Multimedia (ACM Multimedia), 2015 (cited only as the source of the dataset).</a:t>
             </a:r>
           </a:p>
           <a:p>
@@ -6139,7 +6021,20 @@
               <a:rPr sz="1200" b="0">
                 <a:latin typeface="Calibri"/>
               </a:rPr>
-              <a:t>[7] TU Berlin, "Matched Filter and Pulse Compression", chapter of the Scientific Python course, platform.commit.tu-berlin.de/en/book/sci-python/chapter/ch25/section/s01.</a:t>
+              <a:t>[7] K. J. Piczak, ESC-50: Dataset for Environmental Sound Classification (2,000 clips, 50 classes), github.com/karolpiczak/ESC-50.</a:t>
+            </a:r>
+          </a:p>
+          <a:p>
+            <a:pPr>
+              <a:spcAft>
+                <a:spcPts val="600"/>
+              </a:spcAft>
+            </a:pPr>
+            <a:r>
+              <a:rPr sz="1200" b="0">
+                <a:latin typeface="Calibri"/>
+              </a:rPr>
+              <a:t>[8] Creative Commons Attribution-NonCommercial 3.0 licence (CC BY-NC 3.0), creativecommons.org/licenses/by-nc/3.0/.</a:t>
             </a:r>
           </a:p>
         </p:txBody>
@@ -6178,7 +6073,7 @@
                 </a:solidFill>
                 <a:latin typeface="Calibri"/>
               </a:rPr>
-              <a:t>Full list of 18 references in the report. [17] is the base paper.</a:t>
+              <a:t>Full list of 17 references in the report. [1] is the base paper; [6] is cited only as the dataset source.</a:t>
             </a:r>
           </a:p>
         </p:txBody>

</xml_diff>

<commit_message>
Fill in student, guide, department, institute and year in ESC-50 report and slides
Co-Authored-By: Claude Sonnet 5.5 <noreply@anthropic.com>
Claude-Session: https://claude.ai/code/session_012DKUQj8phYpnuRrxK5eNsm
</commit_message>
<xml_diff>
--- a/esc50_matching/docs/presentation.pptx
+++ b/esc50_matching/docs/presentation.pptx
@@ -3266,20 +3266,15 @@
                 </a:solidFill>
                 <a:latin typeface="Calibri"/>
               </a:rPr>
-              <a:t>Student name: </a:t>
-            </a:r>
-            <a:r>
-              <a:rPr sz="1800" b="0">
-                <a:solidFill>
-                  <a:srgbClr val="000000"/>
-                </a:solidFill>
-                <a:latin typeface="Calibri"/>
-                <a:highlight>
-                  <a:srgbClr val="FFFF00"/>
-                </a:highlight>
-              </a:rPr>
-              <a:t>[Student name]</a:t>
-            </a:r>
+              <a:t>Submitted by: Zion Naranje (Roll No. 09)</a:t>
+            </a:r>
+          </a:p>
+          <a:p>
+            <a:pPr>
+              <a:spcAft>
+                <a:spcPts val="600"/>
+              </a:spcAft>
+            </a:pPr>
             <a:r>
               <a:rPr sz="1800" b="0">
                 <a:solidFill>
@@ -3287,19 +3282,7 @@
                 </a:solidFill>
                 <a:latin typeface="Calibri"/>
               </a:rPr>
-              <a:t>     Roll no: </a:t>
-            </a:r>
-            <a:r>
-              <a:rPr sz="1800" b="0">
-                <a:solidFill>
-                  <a:srgbClr val="000000"/>
-                </a:solidFill>
-                <a:latin typeface="Calibri"/>
-                <a:highlight>
-                  <a:srgbClr val="FFFF00"/>
-                </a:highlight>
-              </a:rPr>
-              <a:t>[Roll no]</a:t>
+              <a:t>Guide: Ms. Purvi Agarwal</a:t>
             </a:r>
           </a:p>
           <a:p>
@@ -3315,19 +3298,7 @@
                 </a:solidFill>
                 <a:latin typeface="Calibri"/>
               </a:rPr>
-              <a:t>Guide name: </a:t>
-            </a:r>
-            <a:r>
-              <a:rPr sz="1800" b="0">
-                <a:solidFill>
-                  <a:srgbClr val="000000"/>
-                </a:solidFill>
-                <a:latin typeface="Calibri"/>
-                <a:highlight>
-                  <a:srgbClr val="FFFF00"/>
-                </a:highlight>
-              </a:rPr>
-              <a:t>[Guide name]</a:t>
+              <a:t>Department: Computer Engineering</a:t>
             </a:r>
           </a:p>
           <a:p>
@@ -3343,68 +3314,7 @@
                 </a:solidFill>
                 <a:latin typeface="Calibri"/>
               </a:rPr>
-              <a:t>Department: </a:t>
-            </a:r>
-            <a:r>
-              <a:rPr sz="1800" b="0">
-                <a:solidFill>
-                  <a:srgbClr val="000000"/>
-                </a:solidFill>
-                <a:latin typeface="Calibri"/>
-                <a:highlight>
-                  <a:srgbClr val="FFFF00"/>
-                </a:highlight>
-              </a:rPr>
-              <a:t>[Department]</a:t>
-            </a:r>
-            <a:r>
-              <a:rPr sz="1800" b="0">
-                <a:solidFill>
-                  <a:srgbClr val="FFFFFF"/>
-                </a:solidFill>
-                <a:latin typeface="Calibri"/>
-              </a:rPr>
-              <a:t>     Institute: </a:t>
-            </a:r>
-            <a:r>
-              <a:rPr sz="1800" b="0">
-                <a:solidFill>
-                  <a:srgbClr val="000000"/>
-                </a:solidFill>
-                <a:latin typeface="Calibri"/>
-                <a:highlight>
-                  <a:srgbClr val="FFFF00"/>
-                </a:highlight>
-              </a:rPr>
-              <a:t>[Institute]</a:t>
-            </a:r>
-          </a:p>
-          <a:p>
-            <a:pPr>
-              <a:spcAft>
-                <a:spcPts val="600"/>
-              </a:spcAft>
-            </a:pPr>
-            <a:r>
-              <a:rPr sz="1800" b="0">
-                <a:solidFill>
-                  <a:srgbClr val="FFFFFF"/>
-                </a:solidFill>
-                <a:latin typeface="Calibri"/>
-              </a:rPr>
-              <a:t>Academic year: </a:t>
-            </a:r>
-            <a:r>
-              <a:rPr sz="1800" b="0">
-                <a:solidFill>
-                  <a:srgbClr val="000000"/>
-                </a:solidFill>
-                <a:latin typeface="Calibri"/>
-                <a:highlight>
-                  <a:srgbClr val="FFFF00"/>
-                </a:highlight>
-              </a:rPr>
-              <a:t>[Academic year]</a:t>
+              <a:t>Institute: St. Francis Institute of Technology, 2026-2027</a:t>
             </a:r>
           </a:p>
         </p:txBody>

</xml_diff>